<commit_message>
Updated Project Documents. (Paper and Ppt of Phase2 Stage2)
</commit_message>
<xml_diff>
--- a/Documents/Phase-2 - Stage-2 docs/Project Phase2 Stage2 ppt.pptx
+++ b/Documents/Phase-2 - Stage-2 docs/Project Phase2 Stage2 ppt.pptx
@@ -26,14 +26,14 @@
   <p:notesSz cx="6858000" cy="9144000"/>
   <p:embeddedFontLst>
     <p:embeddedFont>
-      <p:font typeface="Lato" panose="020F0502020204030203" pitchFamily="34" charset="0"/>
+      <p:font typeface="Lato" panose="020B0604020202020204" charset="0"/>
       <p:regular r:id="rId18"/>
       <p:bold r:id="rId19"/>
       <p:italic r:id="rId20"/>
       <p:boldItalic r:id="rId21"/>
     </p:embeddedFont>
     <p:embeddedFont>
-      <p:font typeface="Lato Bold" panose="020F0502020204030203" charset="0"/>
+      <p:font typeface="Lato Bold" panose="020B0604020202020204" charset="0"/>
       <p:regular r:id="rId22"/>
       <p:bold r:id="rId23"/>
     </p:embeddedFont>
@@ -171,59 +171,6 @@
     <p1510:client id="{B03ED4C3-BE3D-4028-8935-D3EAA3B5C102}" v="38" dt="2026-03-25T18:55:17.981"/>
   </p1510:revLst>
 </p1510:revInfo>
-</file>
-
-<file path=ppt/changesInfos/changesInfo1.xml><?xml version="1.0" encoding="utf-8"?>
-<pc:chgInfo xmlns:a="http://schemas.openxmlformats.org/drawingml/2006/main" xmlns:r="http://schemas.openxmlformats.org/officeDocument/2006/relationships" xmlns:ac="http://schemas.microsoft.com/office/drawing/2013/main/command" xmlns:pc="http://schemas.microsoft.com/office/powerpoint/2013/main/command">
-  <pc:docChgLst>
-    <pc:chgData name="SHAM T" userId="f50504b08b6f3d33" providerId="LiveId" clId="{5D1F7783-D6A1-4C7A-81DC-044C58693D50}"/>
-    <pc:docChg chg="custSel modSld">
-      <pc:chgData name="SHAM T" userId="f50504b08b6f3d33" providerId="LiveId" clId="{5D1F7783-D6A1-4C7A-81DC-044C58693D50}" dt="2026-03-25T19:04:26.506" v="3" actId="1076"/>
-      <pc:docMkLst>
-        <pc:docMk/>
-      </pc:docMkLst>
-      <pc:sldChg chg="delSp modSp mod">
-        <pc:chgData name="SHAM T" userId="f50504b08b6f3d33" providerId="LiveId" clId="{5D1F7783-D6A1-4C7A-81DC-044C58693D50}" dt="2026-03-25T19:04:26.506" v="3" actId="1076"/>
-        <pc:sldMkLst>
-          <pc:docMk/>
-          <pc:sldMk cId="3522061369" sldId="272"/>
-        </pc:sldMkLst>
-        <pc:spChg chg="del">
-          <ac:chgData name="SHAM T" userId="f50504b08b6f3d33" providerId="LiveId" clId="{5D1F7783-D6A1-4C7A-81DC-044C58693D50}" dt="2026-03-25T19:04:07.811" v="0" actId="478"/>
-          <ac:spMkLst>
-            <pc:docMk/>
-            <pc:sldMk cId="3522061369" sldId="272"/>
-            <ac:spMk id="7" creationId="{DB540C2B-DB29-756E-E72B-622E41212FD1}"/>
-          </ac:spMkLst>
-        </pc:spChg>
-        <pc:spChg chg="mod">
-          <ac:chgData name="SHAM T" userId="f50504b08b6f3d33" providerId="LiveId" clId="{5D1F7783-D6A1-4C7A-81DC-044C58693D50}" dt="2026-03-25T19:04:18.492" v="1" actId="1076"/>
-          <ac:spMkLst>
-            <pc:docMk/>
-            <pc:sldMk cId="3522061369" sldId="272"/>
-            <ac:spMk id="9" creationId="{28C9275D-DB5E-8859-84A0-8E6726135431}"/>
-          </ac:spMkLst>
-        </pc:spChg>
-        <pc:spChg chg="mod">
-          <ac:chgData name="SHAM T" userId="f50504b08b6f3d33" providerId="LiveId" clId="{5D1F7783-D6A1-4C7A-81DC-044C58693D50}" dt="2026-03-25T19:04:22.062" v="2" actId="1076"/>
-          <ac:spMkLst>
-            <pc:docMk/>
-            <pc:sldMk cId="3522061369" sldId="272"/>
-            <ac:spMk id="11" creationId="{F197B37D-7427-9E2A-012F-870A06EA6EC6}"/>
-          </ac:spMkLst>
-        </pc:spChg>
-        <pc:spChg chg="mod">
-          <ac:chgData name="SHAM T" userId="f50504b08b6f3d33" providerId="LiveId" clId="{5D1F7783-D6A1-4C7A-81DC-044C58693D50}" dt="2026-03-25T19:04:26.506" v="3" actId="1076"/>
-          <ac:spMkLst>
-            <pc:docMk/>
-            <pc:sldMk cId="3522061369" sldId="272"/>
-            <ac:spMk id="13" creationId="{DC2D2F92-E3CA-7054-1B9F-311F10AC3BA8}"/>
-          </ac:spMkLst>
-        </pc:spChg>
-      </pc:sldChg>
-    </pc:docChg>
-  </pc:docChgLst>
-</pc:chgInfo>
 </file>
 
 <file path=ppt/slideLayouts/slideLayout1.xml><?xml version="1.0" encoding="utf-8"?>
@@ -947,7 +894,7 @@
             <a:fld id="{1D8BD707-D9CF-40AE-B4C6-C98DA3205C09}" type="datetimeFigureOut">
               <a:rPr lang="en-US" smtClean="0"/>
               <a:pPr/>
-              <a:t>3/26/2026</a:t>
+              <a:t>3/28/2026</a:t>
             </a:fld>
             <a:endParaRPr lang="en-US"/>
           </a:p>
@@ -1199,7 +1146,7 @@
             <a:fld id="{1D8BD707-D9CF-40AE-B4C6-C98DA3205C09}" type="datetimeFigureOut">
               <a:rPr lang="en-US" smtClean="0"/>
               <a:pPr/>
-              <a:t>3/26/2026</a:t>
+              <a:t>3/28/2026</a:t>
             </a:fld>
             <a:endParaRPr lang="en-US"/>
           </a:p>
@@ -1514,7 +1461,7 @@
             <a:fld id="{1D8BD707-D9CF-40AE-B4C6-C98DA3205C09}" type="datetimeFigureOut">
               <a:rPr lang="en-US" smtClean="0"/>
               <a:pPr/>
-              <a:t>3/26/2026</a:t>
+              <a:t>3/28/2026</a:t>
             </a:fld>
             <a:endParaRPr lang="en-US"/>
           </a:p>
@@ -1856,7 +1803,7 @@
             <a:fld id="{1D8BD707-D9CF-40AE-B4C6-C98DA3205C09}" type="datetimeFigureOut">
               <a:rPr lang="en-US" smtClean="0"/>
               <a:pPr/>
-              <a:t>3/26/2026</a:t>
+              <a:t>3/28/2026</a:t>
             </a:fld>
             <a:endParaRPr lang="en-US"/>
           </a:p>
@@ -2171,7 +2118,7 @@
             <a:fld id="{1D8BD707-D9CF-40AE-B4C6-C98DA3205C09}" type="datetimeFigureOut">
               <a:rPr lang="en-US" smtClean="0"/>
               <a:pPr/>
-              <a:t>3/26/2026</a:t>
+              <a:t>3/28/2026</a:t>
             </a:fld>
             <a:endParaRPr lang="en-US"/>
           </a:p>
@@ -2565,7 +2512,7 @@
             <a:fld id="{1D8BD707-D9CF-40AE-B4C6-C98DA3205C09}" type="datetimeFigureOut">
               <a:rPr lang="en-US" smtClean="0"/>
               <a:pPr/>
-              <a:t>3/26/2026</a:t>
+              <a:t>3/28/2026</a:t>
             </a:fld>
             <a:endParaRPr lang="en-US"/>
           </a:p>
@@ -2735,7 +2682,7 @@
             <a:fld id="{1D8BD707-D9CF-40AE-B4C6-C98DA3205C09}" type="datetimeFigureOut">
               <a:rPr lang="en-US" smtClean="0"/>
               <a:pPr/>
-              <a:t>3/26/2026</a:t>
+              <a:t>3/28/2026</a:t>
             </a:fld>
             <a:endParaRPr lang="en-US"/>
           </a:p>
@@ -2915,7 +2862,7 @@
             <a:fld id="{1D8BD707-D9CF-40AE-B4C6-C98DA3205C09}" type="datetimeFigureOut">
               <a:rPr lang="en-US" smtClean="0"/>
               <a:pPr/>
-              <a:t>3/26/2026</a:t>
+              <a:t>3/28/2026</a:t>
             </a:fld>
             <a:endParaRPr lang="en-US"/>
           </a:p>
@@ -3091,7 +3038,7 @@
             <a:fld id="{1D8BD707-D9CF-40AE-B4C6-C98DA3205C09}" type="datetimeFigureOut">
               <a:rPr lang="en-US" smtClean="0"/>
               <a:pPr/>
-              <a:t>3/26/2026</a:t>
+              <a:t>3/28/2026</a:t>
             </a:fld>
             <a:endParaRPr lang="en-US"/>
           </a:p>
@@ -3339,7 +3286,7 @@
             <a:fld id="{1D8BD707-D9CF-40AE-B4C6-C98DA3205C09}" type="datetimeFigureOut">
               <a:rPr lang="en-US" smtClean="0"/>
               <a:pPr/>
-              <a:t>3/26/2026</a:t>
+              <a:t>3/28/2026</a:t>
             </a:fld>
             <a:endParaRPr lang="en-US"/>
           </a:p>
@@ -3570,7 +3517,7 @@
             <a:fld id="{1D8BD707-D9CF-40AE-B4C6-C98DA3205C09}" type="datetimeFigureOut">
               <a:rPr lang="en-US" smtClean="0"/>
               <a:pPr/>
-              <a:t>3/26/2026</a:t>
+              <a:t>3/28/2026</a:t>
             </a:fld>
             <a:endParaRPr lang="en-US"/>
           </a:p>
@@ -3943,7 +3890,7 @@
             <a:fld id="{1D8BD707-D9CF-40AE-B4C6-C98DA3205C09}" type="datetimeFigureOut">
               <a:rPr lang="en-US" smtClean="0"/>
               <a:pPr/>
-              <a:t>3/26/2026</a:t>
+              <a:t>3/28/2026</a:t>
             </a:fld>
             <a:endParaRPr lang="en-US"/>
           </a:p>
@@ -4067,7 +4014,7 @@
             <a:fld id="{1D8BD707-D9CF-40AE-B4C6-C98DA3205C09}" type="datetimeFigureOut">
               <a:rPr lang="en-US" smtClean="0"/>
               <a:pPr/>
-              <a:t>3/26/2026</a:t>
+              <a:t>3/28/2026</a:t>
             </a:fld>
             <a:endParaRPr lang="en-US"/>
           </a:p>
@@ -4164,7 +4111,7 @@
             <a:fld id="{1D8BD707-D9CF-40AE-B4C6-C98DA3205C09}" type="datetimeFigureOut">
               <a:rPr lang="en-US" smtClean="0"/>
               <a:pPr/>
-              <a:t>3/26/2026</a:t>
+              <a:t>3/28/2026</a:t>
             </a:fld>
             <a:endParaRPr lang="en-US"/>
           </a:p>
@@ -4419,7 +4366,7 @@
             <a:fld id="{1D8BD707-D9CF-40AE-B4C6-C98DA3205C09}" type="datetimeFigureOut">
               <a:rPr lang="en-US" smtClean="0"/>
               <a:pPr/>
-              <a:t>3/26/2026</a:t>
+              <a:t>3/28/2026</a:t>
             </a:fld>
             <a:endParaRPr lang="en-US"/>
           </a:p>
@@ -4682,7 +4629,7 @@
             <a:fld id="{1D8BD707-D9CF-40AE-B4C6-C98DA3205C09}" type="datetimeFigureOut">
               <a:rPr lang="en-US" smtClean="0"/>
               <a:pPr/>
-              <a:t>3/26/2026</a:t>
+              <a:t>3/28/2026</a:t>
             </a:fld>
             <a:endParaRPr lang="en-US"/>
           </a:p>
@@ -4916,6 +4863,13 @@
               <a:schemeClr val="lt1"/>
             </a:fontRef>
           </p:style>
+          <p:txBody>
+            <a:bodyPr/>
+            <a:lstStyle/>
+            <a:p>
+              <a:endParaRPr lang="en-US"/>
+            </a:p>
+          </p:txBody>
         </p:sp>
         <p:sp>
           <p:nvSpPr>
@@ -4979,6 +4933,13 @@
               <a:schemeClr val="lt1"/>
             </a:fontRef>
           </p:style>
+          <p:txBody>
+            <a:bodyPr/>
+            <a:lstStyle/>
+            <a:p>
+              <a:endParaRPr lang="en-US"/>
+            </a:p>
+          </p:txBody>
         </p:sp>
         <p:sp>
           <p:nvSpPr>
@@ -5020,6 +4981,13 @@
               <a:schemeClr val="lt1"/>
             </a:fontRef>
           </p:style>
+          <p:txBody>
+            <a:bodyPr/>
+            <a:lstStyle/>
+            <a:p>
+              <a:endParaRPr lang="en-US"/>
+            </a:p>
+          </p:txBody>
         </p:sp>
         <p:sp>
           <p:nvSpPr>
@@ -5084,6 +5052,13 @@
               <a:schemeClr val="lt1"/>
             </a:fontRef>
           </p:style>
+          <p:txBody>
+            <a:bodyPr/>
+            <a:lstStyle/>
+            <a:p>
+              <a:endParaRPr lang="en-US"/>
+            </a:p>
+          </p:txBody>
         </p:sp>
         <p:sp>
           <p:nvSpPr>
@@ -5149,6 +5124,13 @@
               <a:schemeClr val="lt1"/>
             </a:fontRef>
           </p:style>
+          <p:txBody>
+            <a:bodyPr/>
+            <a:lstStyle/>
+            <a:p>
+              <a:endParaRPr lang="en-US"/>
+            </a:p>
+          </p:txBody>
         </p:sp>
         <p:sp>
           <p:nvSpPr>
@@ -5212,6 +5194,13 @@
               <a:schemeClr val="lt1"/>
             </a:fontRef>
           </p:style>
+          <p:txBody>
+            <a:bodyPr/>
+            <a:lstStyle/>
+            <a:p>
+              <a:endParaRPr lang="en-US"/>
+            </a:p>
+          </p:txBody>
         </p:sp>
         <p:sp>
           <p:nvSpPr>
@@ -5253,6 +5242,13 @@
               <a:schemeClr val="lt1"/>
             </a:fontRef>
           </p:style>
+          <p:txBody>
+            <a:bodyPr/>
+            <a:lstStyle/>
+            <a:p>
+              <a:endParaRPr lang="en-US"/>
+            </a:p>
+          </p:txBody>
         </p:sp>
         <p:sp>
           <p:nvSpPr>
@@ -5294,6 +5290,13 @@
               <a:schemeClr val="lt1"/>
             </a:fontRef>
           </p:style>
+          <p:txBody>
+            <a:bodyPr/>
+            <a:lstStyle/>
+            <a:p>
+              <a:endParaRPr lang="en-US"/>
+            </a:p>
+          </p:txBody>
         </p:sp>
       </p:grpSp>
       <p:sp>
@@ -5425,7 +5428,7 @@
             <a:fld id="{1D8BD707-D9CF-40AE-B4C6-C98DA3205C09}" type="datetimeFigureOut">
               <a:rPr lang="en-US" smtClean="0"/>
               <a:pPr/>
-              <a:t>3/26/2026</a:t>
+              <a:t>3/28/2026</a:t>
             </a:fld>
             <a:endParaRPr lang="en-US"/>
           </a:p>
@@ -5965,13 +5968,13 @@
           <p:nvPr>
             <p:extLst>
               <p:ext uri="{D42A27DB-BD31-4B8C-83A1-F6EECF244321}">
-                <p14:modId xmlns:p14="http://schemas.microsoft.com/office/powerpoint/2010/main" val="3378490024"/>
+                <p14:modId xmlns:p14="http://schemas.microsoft.com/office/powerpoint/2010/main" val="1074481149"/>
               </p:ext>
             </p:extLst>
           </p:nvPr>
         </p:nvGraphicFramePr>
         <p:xfrm>
-          <a:off x="3429000" y="3695700"/>
+          <a:off x="4421457" y="4219807"/>
           <a:ext cx="7696200" cy="2514600"/>
         </p:xfrm>
         <a:graphic>
@@ -6101,7 +6104,7 @@
                     <a:lstStyle/>
                     <a:p>
                       <a:r>
-                        <a:rPr lang="en-IN" sz="2700" kern="1200">
+                        <a:rPr lang="en-IN" sz="2700" kern="1200" dirty="0">
                           <a:solidFill>
                             <a:schemeClr val="dk1"/>
                           </a:solidFill>
@@ -6112,7 +6115,7 @@
                         </a:rPr>
                         <a:t>Jayanth S</a:t>
                       </a:r>
-                      <a:endParaRPr lang="en-IN"/>
+                      <a:endParaRPr lang="en-IN" dirty="0"/>
                     </a:p>
                   </a:txBody>
                   <a:tcPr/>
@@ -6217,7 +6220,7 @@
                     <a:lstStyle/>
                     <a:p>
                       <a:r>
-                        <a:rPr lang="en-IN" sz="2700" kern="1200">
+                        <a:rPr lang="en-IN" sz="2700" kern="1200" dirty="0">
                           <a:solidFill>
                             <a:schemeClr val="dk1"/>
                           </a:solidFill>
@@ -6228,7 +6231,7 @@
                         </a:rPr>
                         <a:t>01JST21CS099</a:t>
                       </a:r>
-                      <a:endParaRPr lang="en-IN"/>
+                      <a:endParaRPr lang="en-IN" dirty="0"/>
                     </a:p>
                   </a:txBody>
                   <a:tcPr/>
@@ -6257,8 +6260,8 @@
         </p:nvSpPr>
         <p:spPr>
           <a:xfrm>
-            <a:off x="914400" y="1104900"/>
-            <a:ext cx="12268200" cy="1800493"/>
+            <a:off x="2135458" y="1283319"/>
+            <a:ext cx="12268200" cy="2654573"/>
           </a:xfrm>
           <a:prstGeom prst="rect">
             <a:avLst/>
@@ -6273,14 +6276,14 @@
           <a:p>
             <a:pPr algn="ctr"/>
             <a:r>
-              <a:rPr lang="en-US" sz="5550">
+              <a:rPr lang="en-US" sz="5550" dirty="0">
                 <a:latin typeface="Lato Bold" panose="020F0502020204030203" charset="0"/>
                 <a:ea typeface="Lato Bold" panose="020F0502020204030203" charset="0"/>
                 <a:cs typeface="Lato Bold" panose="020F0502020204030203" charset="0"/>
               </a:rPr>
-              <a:t>Thermal Foot Analysis for Prediction of DPN using ML</a:t>
-            </a:r>
-            <a:endParaRPr lang="en-IN" sz="5550">
+              <a:t>Thermal Foot Analysis for Prediction of Diabetic Peripheral Neuropathy using ML</a:t>
+            </a:r>
+            <a:endParaRPr lang="en-IN" sz="5550" dirty="0">
               <a:latin typeface="Lato Bold" panose="020F0502020204030203" charset="0"/>
               <a:ea typeface="Lato Bold" panose="020F0502020204030203" charset="0"/>
               <a:cs typeface="Lato Bold" panose="020F0502020204030203" charset="0"/>
@@ -6302,7 +6305,7 @@
         </p:nvSpPr>
         <p:spPr>
           <a:xfrm>
-            <a:off x="6019800" y="6896100"/>
+            <a:off x="6343851" y="7016322"/>
             <a:ext cx="3851413" cy="1951816"/>
           </a:xfrm>
           <a:prstGeom prst="rect">
@@ -6334,7 +6337,7 @@
               <a:buNone/>
             </a:pPr>
             <a:r>
-              <a:rPr lang="en-US" sz="2000" b="1" i="0" u="none" strike="noStrike" cap="none">
+              <a:rPr lang="en-US" sz="2000" b="1" i="0" u="none" strike="noStrike" cap="none" dirty="0">
                 <a:latin typeface="Times New Roman" panose="02020603050405020304"/>
                 <a:ea typeface="Times New Roman" panose="02020603050405020304"/>
                 <a:cs typeface="Times New Roman" panose="02020603050405020304"/>
@@ -6342,7 +6345,7 @@
               </a:rPr>
               <a:t>Under the guidance of</a:t>
             </a:r>
-            <a:endParaRPr lang="en-US" sz="2000" b="0" i="0" u="none" strike="noStrike" cap="none">
+            <a:endParaRPr lang="en-US" sz="2000" b="0" i="0" u="none" strike="noStrike" cap="none" dirty="0">
               <a:latin typeface="Times New Roman" panose="02020603050405020304"/>
               <a:ea typeface="Times New Roman" panose="02020603050405020304"/>
               <a:cs typeface="Times New Roman" panose="02020603050405020304"/>
@@ -6367,7 +6370,7 @@
               <a:buFont typeface="Arial" panose="020B0604020202020204"/>
               <a:buNone/>
             </a:pPr>
-            <a:endParaRPr lang="en-US" sz="2000" b="0" i="0" u="none" strike="noStrike" cap="none">
+            <a:endParaRPr lang="en-US" sz="2000" b="0" i="0" u="none" strike="noStrike" cap="none" dirty="0">
               <a:latin typeface="Times New Roman" panose="02020603050405020304"/>
               <a:ea typeface="Times New Roman" panose="02020603050405020304"/>
               <a:cs typeface="Times New Roman" panose="02020603050405020304"/>
@@ -6393,7 +6396,7 @@
               <a:buNone/>
             </a:pPr>
             <a:r>
-              <a:rPr lang="en-US" sz="2000">
+              <a:rPr lang="en-US" sz="2000" dirty="0">
                 <a:latin typeface="Times New Roman" panose="02020603050405020304"/>
                 <a:ea typeface="Times New Roman" panose="02020603050405020304"/>
                 <a:cs typeface="Times New Roman" panose="02020603050405020304"/>
@@ -6402,7 +6405,7 @@
               <a:t>Prof</a:t>
             </a:r>
             <a:r>
-              <a:rPr lang="en-US" sz="2000" b="0" i="0" u="none" strike="noStrike" cap="none">
+              <a:rPr lang="en-US" sz="2000" b="0" i="0" u="none" strike="noStrike" cap="none" dirty="0">
                 <a:latin typeface="Times New Roman" panose="02020603050405020304"/>
                 <a:ea typeface="Times New Roman" panose="02020603050405020304"/>
                 <a:cs typeface="Times New Roman" panose="02020603050405020304"/>
@@ -6411,7 +6414,7 @@
               <a:t>. </a:t>
             </a:r>
             <a:r>
-              <a:rPr lang="en-US" sz="2000">
+              <a:rPr lang="en-US" sz="2000" dirty="0">
                 <a:latin typeface="Times New Roman" panose="02020603050405020304"/>
                 <a:ea typeface="Times New Roman" panose="02020603050405020304"/>
                 <a:cs typeface="Times New Roman" panose="02020603050405020304"/>
@@ -6419,7 +6422,7 @@
               </a:rPr>
               <a:t>Amaresh A M</a:t>
             </a:r>
-            <a:endParaRPr lang="en-US" sz="2000" b="0" i="0" u="none" strike="noStrike" cap="none">
+            <a:endParaRPr lang="en-US" sz="2000" b="0" i="0" u="none" strike="noStrike" cap="none" dirty="0">
               <a:latin typeface="Times New Roman" panose="02020603050405020304"/>
               <a:ea typeface="Times New Roman" panose="02020603050405020304"/>
               <a:cs typeface="Times New Roman" panose="02020603050405020304"/>
@@ -6445,7 +6448,7 @@
               <a:buNone/>
             </a:pPr>
             <a:r>
-              <a:rPr lang="en-US" sz="2000" b="0" i="0" u="none" strike="noStrike" cap="none">
+              <a:rPr lang="en-US" sz="2000" b="0" i="0" u="none" strike="noStrike" cap="none" dirty="0">
                 <a:latin typeface="Times New Roman" panose="02020603050405020304"/>
                 <a:ea typeface="Times New Roman" panose="02020603050405020304"/>
                 <a:cs typeface="Times New Roman" panose="02020603050405020304"/>
@@ -6473,7 +6476,7 @@
               <a:buNone/>
             </a:pPr>
             <a:r>
-              <a:rPr lang="en-US" sz="2000" b="0" i="0" u="none" strike="noStrike" cap="none">
+              <a:rPr lang="en-US" sz="2000" b="0" i="0" u="none" strike="noStrike" cap="none" dirty="0">
                 <a:latin typeface="Times New Roman" panose="02020603050405020304"/>
                 <a:ea typeface="Times New Roman" panose="02020603050405020304"/>
                 <a:cs typeface="Times New Roman" panose="02020603050405020304"/>
@@ -6501,7 +6504,7 @@
               <a:buNone/>
             </a:pPr>
             <a:r>
-              <a:rPr lang="en-US" sz="2000" b="0" i="0" u="none" strike="noStrike" cap="none">
+              <a:rPr lang="en-US" sz="2000" b="0" i="0" u="none" strike="noStrike" cap="none" dirty="0">
                 <a:latin typeface="Times New Roman" panose="02020603050405020304"/>
                 <a:ea typeface="Times New Roman" panose="02020603050405020304"/>
                 <a:cs typeface="Times New Roman" panose="02020603050405020304"/>
@@ -8707,156 +8710,301 @@
           </a:prstGeom>
         </p:spPr>
       </p:pic>
-      <p:pic>
-        <p:nvPicPr>
-          <p:cNvPr id="17" name="Picture 16">
+      <p:graphicFrame>
+        <p:nvGraphicFramePr>
+          <p:cNvPr id="5" name="Table 4">
             <a:extLst>
               <a:ext uri="{FF2B5EF4-FFF2-40B4-BE49-F238E27FC236}">
-                <a16:creationId xmlns:a16="http://schemas.microsoft.com/office/drawing/2014/main" id="{49697102-C308-D7A6-3A90-BBBDF28BA8C5}"/>
+                <a16:creationId xmlns:a16="http://schemas.microsoft.com/office/drawing/2014/main" id="{9D815211-8EE4-1C45-A928-5031E0552E85}"/>
               </a:ext>
             </a:extLst>
           </p:cNvPr>
-          <p:cNvPicPr>
-            <a:picLocks noChangeAspect="1"/>
-          </p:cNvPicPr>
-          <p:nvPr/>
-        </p:nvPicPr>
-        <p:blipFill>
-          <a:blip r:embed="rId3"/>
-          <a:stretch>
-            <a:fillRect/>
-          </a:stretch>
-        </p:blipFill>
-        <p:spPr>
-          <a:xfrm>
-            <a:off x="8807021" y="7573919"/>
-            <a:ext cx="7562850" cy="1657350"/>
-          </a:xfrm>
-          <a:prstGeom prst="rect">
-            <a:avLst/>
-          </a:prstGeom>
-        </p:spPr>
-      </p:pic>
-      <p:sp>
-        <p:nvSpPr>
-          <p:cNvPr id="18" name="TextBox 17">
-            <a:extLst>
-              <a:ext uri="{FF2B5EF4-FFF2-40B4-BE49-F238E27FC236}">
-                <a16:creationId xmlns:a16="http://schemas.microsoft.com/office/drawing/2014/main" id="{4AAD935D-C4E2-D4A4-9CA8-D9C5A97FD768}"/>
-              </a:ext>
-            </a:extLst>
-          </p:cNvPr>
-          <p:cNvSpPr txBox="1"/>
-          <p:nvPr/>
-        </p:nvSpPr>
-        <p:spPr>
-          <a:xfrm>
-            <a:off x="2857500" y="9499256"/>
-            <a:ext cx="9144000" cy="369332"/>
-          </a:xfrm>
-          <a:prstGeom prst="rect">
-            <a:avLst/>
-          </a:prstGeom>
-          <a:noFill/>
-        </p:spPr>
-        <p:txBody>
-          <a:bodyPr rot="0" spcFirstLastPara="0" vertOverflow="overflow" horzOverflow="overflow" vert="horz" wrap="square" lIns="91440" tIns="45720" rIns="91440" bIns="45720" numCol="1" spcCol="0" rtlCol="0" fromWordArt="0" anchor="t" anchorCtr="0" forceAA="0" compatLnSpc="1">
-            <a:prstTxWarp prst="textNoShape">
-              <a:avLst/>
-            </a:prstTxWarp>
-            <a:spAutoFit/>
-          </a:bodyPr>
-          <a:lstStyle/>
-          <a:p>
-            <a:r>
-              <a:rPr lang="en-IN" i="1">
-                <a:latin typeface="Times New Roman"/>
-                <a:ea typeface="Calibri"/>
-                <a:cs typeface="Times New Roman"/>
-              </a:rPr>
-              <a:t>Hybrid features model</a:t>
-            </a:r>
-            <a:endParaRPr lang="en-US" i="1">
-              <a:latin typeface="Times New Roman"/>
-              <a:ea typeface="Calibri"/>
-              <a:cs typeface="Times New Roman"/>
-            </a:endParaRPr>
-          </a:p>
-        </p:txBody>
-      </p:sp>
-      <p:sp>
-        <p:nvSpPr>
-          <p:cNvPr id="20" name="TextBox 19">
-            <a:extLst>
-              <a:ext uri="{FF2B5EF4-FFF2-40B4-BE49-F238E27FC236}">
-                <a16:creationId xmlns:a16="http://schemas.microsoft.com/office/drawing/2014/main" id="{84D8F25E-4E19-E11F-1E79-DA0BB7F3AB02}"/>
-              </a:ext>
-            </a:extLst>
-          </p:cNvPr>
-          <p:cNvSpPr txBox="1"/>
-          <p:nvPr/>
-        </p:nvSpPr>
-        <p:spPr>
-          <a:xfrm>
-            <a:off x="10863710" y="9502898"/>
-            <a:ext cx="9144000" cy="369332"/>
-          </a:xfrm>
-          <a:prstGeom prst="rect">
-            <a:avLst/>
-          </a:prstGeom>
-          <a:noFill/>
-        </p:spPr>
-        <p:txBody>
-          <a:bodyPr wrap="square" lIns="91440" tIns="45720" rIns="91440" bIns="45720" anchor="t">
-            <a:spAutoFit/>
-          </a:bodyPr>
-          <a:lstStyle/>
-          <a:p>
-            <a:r>
-              <a:rPr lang="en-IN" i="1">
-                <a:latin typeface="Times New Roman"/>
-                <a:ea typeface="+mn-lt"/>
-                <a:cs typeface="Times New Roman"/>
-              </a:rPr>
-              <a:t>CNN-features only model</a:t>
-            </a:r>
-            <a:endParaRPr lang="en-US" i="1">
-              <a:latin typeface="Times New Roman"/>
-              <a:cs typeface="Times New Roman"/>
-            </a:endParaRPr>
-          </a:p>
-        </p:txBody>
-      </p:sp>
-      <p:pic>
-        <p:nvPicPr>
-          <p:cNvPr id="22" name="Picture 21">
-            <a:extLst>
-              <a:ext uri="{FF2B5EF4-FFF2-40B4-BE49-F238E27FC236}">
-                <a16:creationId xmlns:a16="http://schemas.microsoft.com/office/drawing/2014/main" id="{49560FF5-CB6E-B7A0-51EF-F5FA92918E17}"/>
-              </a:ext>
-            </a:extLst>
-          </p:cNvPr>
-          <p:cNvPicPr>
-            <a:picLocks noChangeAspect="1"/>
-          </p:cNvPicPr>
-          <p:nvPr/>
-        </p:nvPicPr>
-        <p:blipFill>
-          <a:blip r:embed="rId4"/>
-          <a:stretch>
-            <a:fillRect/>
-          </a:stretch>
-        </p:blipFill>
-        <p:spPr>
-          <a:xfrm>
-            <a:off x="257719" y="7577388"/>
-            <a:ext cx="8268848" cy="1673710"/>
-          </a:xfrm>
-          <a:prstGeom prst="rect">
-            <a:avLst/>
-          </a:prstGeom>
-        </p:spPr>
-      </p:pic>
+          <p:cNvGraphicFramePr>
+            <a:graphicFrameLocks noGrp="1"/>
+          </p:cNvGraphicFramePr>
+          <p:nvPr>
+            <p:extLst>
+              <p:ext uri="{D42A27DB-BD31-4B8C-83A1-F6EECF244321}">
+                <p14:modId xmlns:p14="http://schemas.microsoft.com/office/powerpoint/2010/main" val="4270509084"/>
+              </p:ext>
+            </p:extLst>
+          </p:nvPr>
+        </p:nvGraphicFramePr>
+        <p:xfrm>
+          <a:off x="695068" y="6663869"/>
+          <a:ext cx="13395960" cy="1752600"/>
+        </p:xfrm>
+        <a:graphic>
+          <a:graphicData uri="http://schemas.openxmlformats.org/drawingml/2006/table">
+            <a:tbl>
+              <a:tblPr firstRow="1" bandRow="1">
+                <a:tableStyleId>{5C22544A-7EE6-4342-B048-85BDC9FD1C3A}</a:tableStyleId>
+              </a:tblPr>
+              <a:tblGrid>
+                <a:gridCol w="4465320">
+                  <a:extLst>
+                    <a:ext uri="{9D8B030D-6E8A-4147-A177-3AD203B41FA5}">
+                      <a16:colId xmlns:a16="http://schemas.microsoft.com/office/drawing/2014/main" val="3657665895"/>
+                    </a:ext>
+                  </a:extLst>
+                </a:gridCol>
+                <a:gridCol w="4465320">
+                  <a:extLst>
+                    <a:ext uri="{9D8B030D-6E8A-4147-A177-3AD203B41FA5}">
+                      <a16:colId xmlns:a16="http://schemas.microsoft.com/office/drawing/2014/main" val="48739182"/>
+                    </a:ext>
+                  </a:extLst>
+                </a:gridCol>
+                <a:gridCol w="4465320">
+                  <a:extLst>
+                    <a:ext uri="{9D8B030D-6E8A-4147-A177-3AD203B41FA5}">
+                      <a16:colId xmlns:a16="http://schemas.microsoft.com/office/drawing/2014/main" val="2595272435"/>
+                    </a:ext>
+                  </a:extLst>
+                </a:gridCol>
+              </a:tblGrid>
+              <a:tr h="370840">
+                <a:tc>
+                  <a:txBody>
+                    <a:bodyPr/>
+                    <a:lstStyle/>
+                    <a:p>
+                      <a:endParaRPr lang="en-IN" sz="1800" dirty="0"/>
+                    </a:p>
+                  </a:txBody>
+                  <a:tcPr/>
+                </a:tc>
+                <a:tc>
+                  <a:txBody>
+                    <a:bodyPr/>
+                    <a:lstStyle/>
+                    <a:p>
+                      <a:pPr marL="0" marR="0" lvl="0" indent="0" algn="l" defTabSz="685800" rtl="0" eaLnBrk="1" fontAlgn="auto" latinLnBrk="0" hangingPunct="1">
+                        <a:lnSpc>
+                          <a:spcPct val="100000"/>
+                        </a:lnSpc>
+                        <a:spcBef>
+                          <a:spcPts val="0"/>
+                        </a:spcBef>
+                        <a:spcAft>
+                          <a:spcPts val="0"/>
+                        </a:spcAft>
+                        <a:buClrTx/>
+                        <a:buSzTx/>
+                        <a:buFontTx/>
+                        <a:buNone/>
+                        <a:tabLst/>
+                        <a:defRPr/>
+                      </a:pPr>
+                      <a:r>
+                        <a:rPr lang="en-IN" sz="1800" i="1" dirty="0">
+                          <a:latin typeface="Times New Roman"/>
+                          <a:ea typeface="Calibri"/>
+                          <a:cs typeface="Times New Roman"/>
+                        </a:rPr>
+                        <a:t>Hybrid features model</a:t>
+                      </a:r>
+                      <a:endParaRPr lang="en-US" sz="1800" i="1" dirty="0">
+                        <a:latin typeface="Times New Roman"/>
+                        <a:ea typeface="Calibri"/>
+                        <a:cs typeface="Times New Roman"/>
+                      </a:endParaRPr>
+                    </a:p>
+                    <a:p>
+                      <a:endParaRPr lang="en-IN" sz="1800" dirty="0"/>
+                    </a:p>
+                  </a:txBody>
+                  <a:tcPr/>
+                </a:tc>
+                <a:tc>
+                  <a:txBody>
+                    <a:bodyPr/>
+                    <a:lstStyle/>
+                    <a:p>
+                      <a:pPr marL="0" marR="0" lvl="0" indent="0" algn="l" defTabSz="685800" rtl="0" eaLnBrk="1" fontAlgn="auto" latinLnBrk="0" hangingPunct="1">
+                        <a:lnSpc>
+                          <a:spcPct val="100000"/>
+                        </a:lnSpc>
+                        <a:spcBef>
+                          <a:spcPts val="0"/>
+                        </a:spcBef>
+                        <a:spcAft>
+                          <a:spcPts val="0"/>
+                        </a:spcAft>
+                        <a:buClrTx/>
+                        <a:buSzTx/>
+                        <a:buFontTx/>
+                        <a:buNone/>
+                        <a:tabLst/>
+                        <a:defRPr/>
+                      </a:pPr>
+                      <a:r>
+                        <a:rPr lang="en-IN" sz="1800" i="1" dirty="0">
+                          <a:latin typeface="Times New Roman"/>
+                          <a:ea typeface="+mn-lt"/>
+                          <a:cs typeface="Times New Roman"/>
+                        </a:rPr>
+                        <a:t>CNN-features only model</a:t>
+                      </a:r>
+                      <a:endParaRPr lang="en-US" sz="1800" i="1" dirty="0">
+                        <a:latin typeface="Times New Roman"/>
+                        <a:cs typeface="Times New Roman"/>
+                      </a:endParaRPr>
+                    </a:p>
+                    <a:p>
+                      <a:endParaRPr lang="en-IN" sz="1800" dirty="0"/>
+                    </a:p>
+                  </a:txBody>
+                  <a:tcPr/>
+                </a:tc>
+                <a:extLst>
+                  <a:ext uri="{0D108BD9-81ED-4DB2-BD59-A6C34878D82A}">
+                    <a16:rowId xmlns:a16="http://schemas.microsoft.com/office/drawing/2014/main" val="4047464550"/>
+                  </a:ext>
+                </a:extLst>
+              </a:tr>
+              <a:tr h="370840">
+                <a:tc>
+                  <a:txBody>
+                    <a:bodyPr/>
+                    <a:lstStyle/>
+                    <a:p>
+                      <a:r>
+                        <a:rPr lang="en-IN" sz="1800" dirty="0"/>
+                        <a:t>Root Mean Square Error (RMS)</a:t>
+                      </a:r>
+                    </a:p>
+                  </a:txBody>
+                  <a:tcPr/>
+                </a:tc>
+                <a:tc>
+                  <a:txBody>
+                    <a:bodyPr/>
+                    <a:lstStyle/>
+                    <a:p>
+                      <a:r>
+                        <a:rPr lang="en-IN" sz="1800" dirty="0"/>
+                        <a:t>0.473100</a:t>
+                      </a:r>
+                    </a:p>
+                  </a:txBody>
+                  <a:tcPr/>
+                </a:tc>
+                <a:tc>
+                  <a:txBody>
+                    <a:bodyPr/>
+                    <a:lstStyle/>
+                    <a:p>
+                      <a:r>
+                        <a:rPr lang="en-IN" sz="1800" dirty="0"/>
+                        <a:t>0.610200</a:t>
+                      </a:r>
+                    </a:p>
+                  </a:txBody>
+                  <a:tcPr/>
+                </a:tc>
+                <a:extLst>
+                  <a:ext uri="{0D108BD9-81ED-4DB2-BD59-A6C34878D82A}">
+                    <a16:rowId xmlns:a16="http://schemas.microsoft.com/office/drawing/2014/main" val="701984428"/>
+                  </a:ext>
+                </a:extLst>
+              </a:tr>
+              <a:tr h="370840">
+                <a:tc>
+                  <a:txBody>
+                    <a:bodyPr/>
+                    <a:lstStyle/>
+                    <a:p>
+                      <a:r>
+                        <a:rPr lang="en-IN" sz="1800" dirty="0"/>
+                        <a:t>Mean Square Error (MAE)</a:t>
+                      </a:r>
+                    </a:p>
+                  </a:txBody>
+                  <a:tcPr/>
+                </a:tc>
+                <a:tc>
+                  <a:txBody>
+                    <a:bodyPr/>
+                    <a:lstStyle/>
+                    <a:p>
+                      <a:r>
+                        <a:rPr lang="en-IN" sz="1800" dirty="0"/>
+                        <a:t>0.357319</a:t>
+                      </a:r>
+                    </a:p>
+                  </a:txBody>
+                  <a:tcPr/>
+                </a:tc>
+                <a:tc>
+                  <a:txBody>
+                    <a:bodyPr/>
+                    <a:lstStyle/>
+                    <a:p>
+                      <a:r>
+                        <a:rPr lang="en-IN" sz="1800" dirty="0"/>
+                        <a:t>0.498862</a:t>
+                      </a:r>
+                    </a:p>
+                  </a:txBody>
+                  <a:tcPr/>
+                </a:tc>
+                <a:extLst>
+                  <a:ext uri="{0D108BD9-81ED-4DB2-BD59-A6C34878D82A}">
+                    <a16:rowId xmlns:a16="http://schemas.microsoft.com/office/drawing/2014/main" val="1681481764"/>
+                  </a:ext>
+                </a:extLst>
+              </a:tr>
+              <a:tr h="370840">
+                <a:tc>
+                  <a:txBody>
+                    <a:bodyPr/>
+                    <a:lstStyle/>
+                    <a:p>
+                      <a:r>
+                        <a:rPr lang="en-IN" sz="1800" dirty="0"/>
+                        <a:t>Ordinal Accuracy</a:t>
+                      </a:r>
+                    </a:p>
+                  </a:txBody>
+                  <a:tcPr/>
+                </a:tc>
+                <a:tc>
+                  <a:txBody>
+                    <a:bodyPr/>
+                    <a:lstStyle/>
+                    <a:p>
+                      <a:r>
+                        <a:rPr lang="en-IN" sz="1800" dirty="0"/>
+                        <a:t>0.995102</a:t>
+                      </a:r>
+                    </a:p>
+                  </a:txBody>
+                  <a:tcPr/>
+                </a:tc>
+                <a:tc>
+                  <a:txBody>
+                    <a:bodyPr/>
+                    <a:lstStyle/>
+                    <a:p>
+                      <a:r>
+                        <a:rPr lang="en-IN" sz="1800" dirty="0"/>
+                        <a:t>0.99162</a:t>
+                      </a:r>
+                    </a:p>
+                  </a:txBody>
+                  <a:tcPr/>
+                </a:tc>
+                <a:extLst>
+                  <a:ext uri="{0D108BD9-81ED-4DB2-BD59-A6C34878D82A}">
+                    <a16:rowId xmlns:a16="http://schemas.microsoft.com/office/drawing/2014/main" val="390370678"/>
+                  </a:ext>
+                </a:extLst>
+              </a:tr>
+            </a:tbl>
+          </a:graphicData>
+        </a:graphic>
+      </p:graphicFrame>
     </p:spTree>
     <p:extLst>
       <p:ext uri="{BB962C8B-B14F-4D97-AF65-F5344CB8AC3E}">
@@ -13530,7 +13678,7 @@
     </a:clrScheme>
     <a:fontScheme name="Facet">
       <a:majorFont>
-        <a:latin typeface="Trebuchet MS" panose="020B0603020202020204"/>
+        <a:latin typeface="Trebuchet MS"/>
         <a:ea typeface=""/>
         <a:cs typeface=""/>
         <a:font script="Jpan" typeface="メイリオ"/>
@@ -13565,7 +13713,7 @@
         <a:font script="Geor" typeface="Sylfaen"/>
       </a:majorFont>
       <a:minorFont>
-        <a:latin typeface="Trebuchet MS" panose="020B0603020202020204"/>
+        <a:latin typeface="Trebuchet MS"/>
         <a:ea typeface=""/>
         <a:cs typeface=""/>
         <a:font script="Jpan" typeface="メイリオ"/>

</xml_diff>

<commit_message>
Phase 2 Stage 3 Project Documents and updated Phase 2 Stage 2 ppt.
</commit_message>
<xml_diff>
--- a/Documents/Phase-2 - Stage-2 docs/Project Phase2 Stage2 ppt.pptx
+++ b/Documents/Phase-2 - Stage-2 docs/Project Phase2 Stage2 ppt.pptx
@@ -894,7 +894,7 @@
             <a:fld id="{1D8BD707-D9CF-40AE-B4C6-C98DA3205C09}" type="datetimeFigureOut">
               <a:rPr lang="en-US" smtClean="0"/>
               <a:pPr/>
-              <a:t>3/28/2026</a:t>
+              <a:t>4/28/2026</a:t>
             </a:fld>
             <a:endParaRPr lang="en-US"/>
           </a:p>
@@ -1146,7 +1146,7 @@
             <a:fld id="{1D8BD707-D9CF-40AE-B4C6-C98DA3205C09}" type="datetimeFigureOut">
               <a:rPr lang="en-US" smtClean="0"/>
               <a:pPr/>
-              <a:t>3/28/2026</a:t>
+              <a:t>4/28/2026</a:t>
             </a:fld>
             <a:endParaRPr lang="en-US"/>
           </a:p>
@@ -1461,7 +1461,7 @@
             <a:fld id="{1D8BD707-D9CF-40AE-B4C6-C98DA3205C09}" type="datetimeFigureOut">
               <a:rPr lang="en-US" smtClean="0"/>
               <a:pPr/>
-              <a:t>3/28/2026</a:t>
+              <a:t>4/28/2026</a:t>
             </a:fld>
             <a:endParaRPr lang="en-US"/>
           </a:p>
@@ -1803,7 +1803,7 @@
             <a:fld id="{1D8BD707-D9CF-40AE-B4C6-C98DA3205C09}" type="datetimeFigureOut">
               <a:rPr lang="en-US" smtClean="0"/>
               <a:pPr/>
-              <a:t>3/28/2026</a:t>
+              <a:t>4/28/2026</a:t>
             </a:fld>
             <a:endParaRPr lang="en-US"/>
           </a:p>
@@ -2118,7 +2118,7 @@
             <a:fld id="{1D8BD707-D9CF-40AE-B4C6-C98DA3205C09}" type="datetimeFigureOut">
               <a:rPr lang="en-US" smtClean="0"/>
               <a:pPr/>
-              <a:t>3/28/2026</a:t>
+              <a:t>4/28/2026</a:t>
             </a:fld>
             <a:endParaRPr lang="en-US"/>
           </a:p>
@@ -2512,7 +2512,7 @@
             <a:fld id="{1D8BD707-D9CF-40AE-B4C6-C98DA3205C09}" type="datetimeFigureOut">
               <a:rPr lang="en-US" smtClean="0"/>
               <a:pPr/>
-              <a:t>3/28/2026</a:t>
+              <a:t>4/28/2026</a:t>
             </a:fld>
             <a:endParaRPr lang="en-US"/>
           </a:p>
@@ -2682,7 +2682,7 @@
             <a:fld id="{1D8BD707-D9CF-40AE-B4C6-C98DA3205C09}" type="datetimeFigureOut">
               <a:rPr lang="en-US" smtClean="0"/>
               <a:pPr/>
-              <a:t>3/28/2026</a:t>
+              <a:t>4/28/2026</a:t>
             </a:fld>
             <a:endParaRPr lang="en-US"/>
           </a:p>
@@ -2862,7 +2862,7 @@
             <a:fld id="{1D8BD707-D9CF-40AE-B4C6-C98DA3205C09}" type="datetimeFigureOut">
               <a:rPr lang="en-US" smtClean="0"/>
               <a:pPr/>
-              <a:t>3/28/2026</a:t>
+              <a:t>4/28/2026</a:t>
             </a:fld>
             <a:endParaRPr lang="en-US"/>
           </a:p>
@@ -3038,7 +3038,7 @@
             <a:fld id="{1D8BD707-D9CF-40AE-B4C6-C98DA3205C09}" type="datetimeFigureOut">
               <a:rPr lang="en-US" smtClean="0"/>
               <a:pPr/>
-              <a:t>3/28/2026</a:t>
+              <a:t>4/28/2026</a:t>
             </a:fld>
             <a:endParaRPr lang="en-US"/>
           </a:p>
@@ -3286,7 +3286,7 @@
             <a:fld id="{1D8BD707-D9CF-40AE-B4C6-C98DA3205C09}" type="datetimeFigureOut">
               <a:rPr lang="en-US" smtClean="0"/>
               <a:pPr/>
-              <a:t>3/28/2026</a:t>
+              <a:t>4/28/2026</a:t>
             </a:fld>
             <a:endParaRPr lang="en-US"/>
           </a:p>
@@ -3517,7 +3517,7 @@
             <a:fld id="{1D8BD707-D9CF-40AE-B4C6-C98DA3205C09}" type="datetimeFigureOut">
               <a:rPr lang="en-US" smtClean="0"/>
               <a:pPr/>
-              <a:t>3/28/2026</a:t>
+              <a:t>4/28/2026</a:t>
             </a:fld>
             <a:endParaRPr lang="en-US"/>
           </a:p>
@@ -3890,7 +3890,7 @@
             <a:fld id="{1D8BD707-D9CF-40AE-B4C6-C98DA3205C09}" type="datetimeFigureOut">
               <a:rPr lang="en-US" smtClean="0"/>
               <a:pPr/>
-              <a:t>3/28/2026</a:t>
+              <a:t>4/28/2026</a:t>
             </a:fld>
             <a:endParaRPr lang="en-US"/>
           </a:p>
@@ -4014,7 +4014,7 @@
             <a:fld id="{1D8BD707-D9CF-40AE-B4C6-C98DA3205C09}" type="datetimeFigureOut">
               <a:rPr lang="en-US" smtClean="0"/>
               <a:pPr/>
-              <a:t>3/28/2026</a:t>
+              <a:t>4/28/2026</a:t>
             </a:fld>
             <a:endParaRPr lang="en-US"/>
           </a:p>
@@ -4111,7 +4111,7 @@
             <a:fld id="{1D8BD707-D9CF-40AE-B4C6-C98DA3205C09}" type="datetimeFigureOut">
               <a:rPr lang="en-US" smtClean="0"/>
               <a:pPr/>
-              <a:t>3/28/2026</a:t>
+              <a:t>4/28/2026</a:t>
             </a:fld>
             <a:endParaRPr lang="en-US"/>
           </a:p>
@@ -4366,7 +4366,7 @@
             <a:fld id="{1D8BD707-D9CF-40AE-B4C6-C98DA3205C09}" type="datetimeFigureOut">
               <a:rPr lang="en-US" smtClean="0"/>
               <a:pPr/>
-              <a:t>3/28/2026</a:t>
+              <a:t>4/28/2026</a:t>
             </a:fld>
             <a:endParaRPr lang="en-US"/>
           </a:p>
@@ -4629,7 +4629,7 @@
             <a:fld id="{1D8BD707-D9CF-40AE-B4C6-C98DA3205C09}" type="datetimeFigureOut">
               <a:rPr lang="en-US" smtClean="0"/>
               <a:pPr/>
-              <a:t>3/28/2026</a:t>
+              <a:t>4/28/2026</a:t>
             </a:fld>
             <a:endParaRPr lang="en-US"/>
           </a:p>
@@ -5428,7 +5428,7 @@
             <a:fld id="{1D8BD707-D9CF-40AE-B4C6-C98DA3205C09}" type="datetimeFigureOut">
               <a:rPr lang="en-US" smtClean="0"/>
               <a:pPr/>
-              <a:t>3/28/2026</a:t>
+              <a:t>4/28/2026</a:t>
             </a:fld>
             <a:endParaRPr lang="en-US"/>
           </a:p>
@@ -9528,7 +9528,7 @@
           <a:lstStyle/>
           <a:p>
             <a:r>
-              <a:rPr lang="en-US" sz="4400">
+              <a:rPr lang="en-US" sz="4400" dirty="0">
                 <a:solidFill>
                   <a:srgbClr val="282824"/>
                 </a:solidFill>
@@ -9537,7 +9537,7 @@
               </a:rPr>
               <a:t>Application Workflow and Risk Mapping</a:t>
             </a:r>
-            <a:endParaRPr lang="en-US"/>
+            <a:endParaRPr lang="en-US" dirty="0"/>
           </a:p>
         </p:txBody>
       </p:sp>
@@ -10836,10 +10836,10 @@
             </a:pathLst>
           </a:custGeom>
           <a:blipFill>
-            <a:blip r:embed="rId2">
+            <a:blip>
               <a:extLst>
                 <a:ext uri="{96DAC541-7B7A-43D3-8B79-37D633B846F1}">
-                  <asvg:svgBlip xmlns:asvg="http://schemas.microsoft.com/office/drawing/2016/SVG/main" r:embed="rId3"/>
+                  <asvg:svgBlip xmlns:asvg="http://schemas.microsoft.com/office/drawing/2016/SVG/main" r:embed="rId2"/>
                 </a:ext>
               </a:extLst>
             </a:blip>
@@ -10977,10 +10977,10 @@
             </a:pathLst>
           </a:custGeom>
           <a:blipFill>
-            <a:blip r:embed="rId2">
+            <a:blip>
               <a:extLst>
                 <a:ext uri="{96DAC541-7B7A-43D3-8B79-37D633B846F1}">
-                  <asvg:svgBlip xmlns:asvg="http://schemas.microsoft.com/office/drawing/2016/SVG/main" r:embed="rId3"/>
+                  <asvg:svgBlip xmlns:asvg="http://schemas.microsoft.com/office/drawing/2016/SVG/main" r:embed="rId2"/>
                 </a:ext>
               </a:extLst>
             </a:blip>
@@ -11118,10 +11118,10 @@
             </a:pathLst>
           </a:custGeom>
           <a:blipFill>
-            <a:blip r:embed="rId2">
+            <a:blip>
               <a:extLst>
                 <a:ext uri="{96DAC541-7B7A-43D3-8B79-37D633B846F1}">
-                  <asvg:svgBlip xmlns:asvg="http://schemas.microsoft.com/office/drawing/2016/SVG/main" r:embed="rId3"/>
+                  <asvg:svgBlip xmlns:asvg="http://schemas.microsoft.com/office/drawing/2016/SVG/main" r:embed="rId2"/>
                 </a:ext>
               </a:extLst>
             </a:blip>
@@ -11259,10 +11259,10 @@
             </a:pathLst>
           </a:custGeom>
           <a:blipFill>
-            <a:blip r:embed="rId2">
+            <a:blip>
               <a:extLst>
                 <a:ext uri="{96DAC541-7B7A-43D3-8B79-37D633B846F1}">
-                  <asvg:svgBlip xmlns:asvg="http://schemas.microsoft.com/office/drawing/2016/SVG/main" r:embed="rId3"/>
+                  <asvg:svgBlip xmlns:asvg="http://schemas.microsoft.com/office/drawing/2016/SVG/main" r:embed="rId2"/>
                 </a:ext>
               </a:extLst>
             </a:blip>
@@ -11376,7 +11376,7 @@
           <p:nvPr/>
         </p:nvPicPr>
         <p:blipFill>
-          <a:blip r:embed="rId4"/>
+          <a:blip r:embed="rId3"/>
           <a:stretch>
             <a:fillRect/>
           </a:stretch>

</xml_diff>